<commit_message>
Update the slide deck for geofence entry/exit alerts and PM2 auto-start
Cover and index reflect the 24/09 update; Notificaciones now shows the
"Salida de geocerca" alert and its ATENCION/ALARMA Telegram message plus
when alerts fire (day: geofence entry/exit; night: 8:00, 8:30, 9:00pm);
the closing stats say 75 units, ALARMA/ATENCION and automatic restart.

Co-Authored-By: Claude Opus 5.5 <noreply@anthropic.com>
</commit_message>
<xml_diff>
--- a/informes/Tracker_GPS_de_Flota.pptx
+++ b/informes/Tracker_GPS_de_Flota.pptx
@@ -1560,7 +1560,7 @@
                 <a:ea typeface="Calibri" pitchFamily="34" charset="-122"/>
                 <a:cs typeface="Calibri" pitchFamily="34" charset="-120"/>
               </a:rPr>
-              <a:t>ACTUALIZACIÓN · RECORRIDOS, TELEGRAM Y RETENCIÓN AUTOMÁTICA</a:t>
+              <a:t>ACTUALIZACIÓN · GEOCERCAS, HORARIOS DE ALERTA Y ARRANQUE AUTOMÁTICO</a:t>
             </a:r>
             <a:endParaRPr lang="en-US" sz="1050" dirty="0"/>
           </a:p>
@@ -1641,7 +1641,7 @@
                 <a:ea typeface="Calibri" pitchFamily="34" charset="-122"/>
                 <a:cs typeface="Calibri" pitchFamily="34" charset="-120"/>
               </a:rPr>
-              <a:t>18 de septiembre de 2026</a:t>
+              <a:t>24 de septiembre de 2026</a:t>
             </a:r>
             <a:endParaRPr lang="en-US" sz="1100" dirty="0"/>
           </a:p>
@@ -2450,7 +2450,7 @@
                   </a:extLst>
                 </a:hlinkClick>
               </a:rPr>
-              <a:t>Alarmas automáticas, su recorrido asociado y el mensaje real que llega a Telegram.</a:t>
+              <a:t>Entradas y salidas de geocerca de día, fuera de horario de noche, y el mensaje real de Telegram.</a:t>
             </a:r>
             <a:endParaRPr lang="en-US" sz="1100" dirty="0"/>
           </a:p>
@@ -3345,7 +3345,7 @@
                 <a:ea typeface="Calibri" pitchFamily="34" charset="-122"/>
                 <a:cs typeface="Calibri" pitchFamily="34" charset="-120"/>
               </a:rPr>
-              <a:t>Se sincroniza sola cada 10 minutos; "Sincronizar ahora" fuerza una consulta en vivo.</a:t>
+              <a:t>Se sincroniza sola en horarios fijos (turnos y revisiones nocturnas); "Sincronizar ahora" fuerza una consulta en vivo.</a:t>
             </a:r>
             <a:endParaRPr lang="en-US" sz="1150" dirty="0"/>
           </a:p>
@@ -5632,7 +5632,7 @@
                 <a:ea typeface="Calibri" pitchFamily="34" charset="-122"/>
                 <a:cs typeface="Calibri" pitchFamily="34" charset="-120"/>
               </a:rPr>
-              <a:t>Fuera de zona</a:t>
+              <a:t>Salida de geocerca</a:t>
             </a:r>
             <a:endParaRPr lang="en-US" sz="750" dirty="0"/>
           </a:p>
@@ -5671,7 +5671,7 @@
                 <a:ea typeface="Calibri" pitchFamily="34" charset="-122"/>
                 <a:cs typeface="Calibri" pitchFamily="34" charset="-120"/>
               </a:rPr>
-              <a:t>🚨 Unidad fuera del perímetro permitido</a:t>
+              <a:t>🔴 Unidad saliendo de geocerca Boscán</a:t>
             </a:r>
             <a:endParaRPr lang="en-US" sz="850" dirty="0"/>
           </a:p>
@@ -5955,7 +5955,7 @@
                 <a:ea typeface="Cambria" pitchFamily="34" charset="-122"/>
                 <a:cs typeface="Cambria" pitchFamily="34" charset="-120"/>
               </a:rPr>
-              <a:t>🛣️  Recorrido — Fuera de la geocerca — FP-VEH.02-16</a:t>
+              <a:t>🛣️  Recorrido — Entrada/salida de geocerca — FP-VEH.02-16</a:t>
             </a:r>
             <a:endParaRPr lang="en-US" sz="1250" dirty="0"/>
           </a:p>
@@ -6849,7 +6849,7 @@
                 <a:ea typeface="Consolas" pitchFamily="34" charset="-122"/>
                 <a:cs typeface="Consolas" pitchFamily="34" charset="-120"/>
               </a:rPr>
-              <a:t>🚨 ALERTA - Fuera de geocerca</a:t>
+              <a:t>⚠️ ATENCIÓN - 🔴 Unidad saliendo de geocerca</a:t>
             </a:r>
             <a:endParaRPr lang="en-US" sz="900" dirty="0"/>
           </a:p>
@@ -6909,7 +6909,7 @@
                 <a:ea typeface="Consolas" pitchFamily="34" charset="-122"/>
                 <a:cs typeface="Consolas" pitchFamily="34" charset="-120"/>
               </a:rPr>
-              <a:t>Ubicación: BASE FULLPETRO - CAMPO BOSCÁN</a:t>
+              <a:t>Geocerca: Boscán   ·   Ubicación: Km 40, La Cañada</a:t>
             </a:r>
             <a:endParaRPr lang="en-US" sz="900" dirty="0"/>
           </a:p>
@@ -6929,7 +6929,7 @@
                 <a:ea typeface="Consolas" pitchFamily="34" charset="-122"/>
                 <a:cs typeface="Consolas" pitchFamily="34" charset="-120"/>
               </a:rPr>
-              <a:t>Motivo: Unidad fuera del perímetro permitido</a:t>
+              <a:t>Velocidad: 55 km/h   ·   Mapa: enlace a Google Maps</a:t>
             </a:r>
             <a:endParaRPr lang="en-US" sz="900" dirty="0"/>
           </a:p>
@@ -7741,7 +7741,7 @@
                 <a:ea typeface="Calibri" pitchFamily="34" charset="-122"/>
                 <a:cs typeface="Calibri" pitchFamily="34" charset="-120"/>
               </a:rPr>
-              <a:t>🧹  Limpieza automática de alertas</a:t>
+              <a:t>🕗  Cuándo avisa  ·  🧹  Limpieza automática</a:t>
             </a:r>
             <a:endParaRPr lang="en-US" sz="1050" dirty="0"/>
           </a:p>
@@ -7780,7 +7780,7 @@
                 <a:ea typeface="Calibri" pitchFamily="34" charset="-122"/>
                 <a:cs typeface="Calibri" pitchFamily="34" charset="-120"/>
               </a:rPr>
-              <a:t>El historial de alertas se elimina solo, todos los días, después de 8 días — información "solo de revisión" que no debe crecer sin límite ni arriesgar el sistema.</a:t>
+              <a:t>De día: cada entrada/salida de geocerca que marca GEvolution (🚨 ALARMA si es crítica, ⚠️ ATENCIÓN si no). De noche: fuera de horario a las 8:00, 8:30 y 9:00 pm. El historial se borra solo a los 8 días.</a:t>
             </a:r>
             <a:endParaRPr lang="en-US" sz="950" dirty="0"/>
           </a:p>
@@ -8243,7 +8243,7 @@
                 <a:ea typeface="Cambria" pitchFamily="34" charset="-122"/>
                 <a:cs typeface="Cambria" pitchFamily="34" charset="-120"/>
               </a:rPr>
-              <a:t>70</a:t>
+              <a:t>75</a:t>
             </a:r>
             <a:endParaRPr lang="en-US" sz="2600" dirty="0"/>
           </a:p>
@@ -8377,7 +8377,7 @@
                 <a:ea typeface="Calibri" pitchFamily="34" charset="-122"/>
                 <a:cs typeface="Calibri" pitchFamily="34" charset="-120"/>
               </a:rPr>
-              <a:t>sincronización y</a:t>
+              <a:t>arranque y recuperación</a:t>
             </a:r>
             <a:endParaRPr lang="en-US" sz="950" dirty="0"/>
           </a:p>
@@ -8394,7 +8394,7 @@
                 <a:ea typeface="Calibri" pitchFamily="34" charset="-122"/>
                 <a:cs typeface="Calibri" pitchFamily="34" charset="-120"/>
               </a:rPr>
-              <a:t>evaluación automática</a:t>
+              <a:t>automática, sin ventanas</a:t>
             </a:r>
             <a:endParaRPr lang="en-US" sz="950" dirty="0"/>
           </a:p>
@@ -8489,7 +8489,7 @@
                 <a:ea typeface="Calibri" pitchFamily="34" charset="-122"/>
                 <a:cs typeface="Calibri" pitchFamily="34" charset="-120"/>
               </a:rPr>
-              <a:t>según tipo de flota</a:t>
+              <a:t>ALARMA y ATENCIÓN</a:t>
             </a:r>
             <a:endParaRPr lang="en-US" sz="950" dirty="0"/>
           </a:p>

</xml_diff>